<commit_message>
Add self-learning content to the pitch deck (Wrexlyn-Pitch-Deck.pptx)
- Slide 8 "How this differs": new "Learns your preferences" row
  (remembers preferences & past mistakes vs. resetting every session).
- New slide 10, "It remembers what you tell it — and what it got wrong":
  a 3-column comparison table covering remember_preference (preferences
  persist and apply immediately, not next session) and save_skill/
  recall_skill (reusable multi-step patterns saved instead of re-derived
  from scratch), placed right after the document-generation slide.
- Deck grows from 14 to 15 slides; verified via PowerPoint COM automation
  (opens cleanly, correct slide/shape counts) and visual export of both
  the edited and new slide.
</commit_message>
<xml_diff>
--- a/docs/assets/Wrexlyn-Pitch-Deck.pptx
+++ b/docs/assets/Wrexlyn-Pitch-Deck.pptx
@@ -14,6 +14,7 @@
     <p:sldId id="262" r:id="rId8"/>
     <p:sldId id="263" r:id="rId9"/>
     <p:sldId id="264" r:id="rId10"/>
+    <p:sldId id="270" r:id="rId21"/>
     <p:sldId id="265" r:id="rId11"/>
     <p:sldId id="266" r:id="rId12"/>
     <p:sldId id="267" r:id="rId13"/>
@@ -5748,6 +5749,903 @@
 </p:sld>
 </file>
 
+<file path=ppt/slides/slide15.xml><?xml version="1.0" encoding="utf-8"?>
+<p:sld xmlns:a="http://schemas.openxmlformats.org/drawingml/2006/main" xmlns:r="http://schemas.openxmlformats.org/officeDocument/2006/relationships" xmlns:p="http://schemas.openxmlformats.org/presentationml/2006/main">
+  <p:cSld name="Slide 15">
+    <p:bg>
+      <p:bgPr>
+        <a:solidFill>
+          <a:srgbClr val="FFFFFF"/>
+        </a:solidFill>
+      </p:bgPr>
+    </p:bg>
+    <p:spTree>
+      <p:nvGrpSpPr>
+        <p:cNvPr id="1" name=""/>
+        <p:cNvGrpSpPr/>
+        <p:nvPr/>
+      </p:nvGrpSpPr>
+      <p:grpSpPr>
+        <a:xfrm>
+          <a:off x="0" y="0"/>
+          <a:ext cx="0" cy="0"/>
+          <a:chOff x="0" y="0"/>
+          <a:chExt cx="0" cy="0"/>
+        </a:xfrm>
+      </p:grpSpPr>
+      <p:sp>
+        <p:nvSpPr>
+          <p:cNvPr id="2" name="Text 0"/>
+          <p:cNvSpPr/>
+          <p:nvPr/>
+        </p:nvSpPr>
+        <p:spPr>
+          <a:xfrm>
+            <a:off x="457200" y="320040"/>
+            <a:ext cx="8229600" cy="822960"/>
+          </a:xfrm>
+          <a:prstGeom prst="rect">
+            <a:avLst/>
+          </a:prstGeom>
+          <a:noFill/>
+          <a:ln/>
+        </p:spPr>
+        <p:txBody>
+          <a:bodyPr wrap="square" rtlCol="0" anchor="ctr"/>
+          <a:lstStyle/>
+          <a:p>
+            <a:pPr indent="0" marL="0">
+              <a:buNone/>
+            </a:pPr>
+            <a:r>
+              <a:rPr lang="en-US" sz="3600" b="1" dirty="0">
+                <a:solidFill>
+                  <a:srgbClr val="1F2937"/>
+                </a:solidFill>
+                <a:latin typeface="Calibri" pitchFamily="34" charset="0"/>
+                <a:ea typeface="Calibri" pitchFamily="34" charset="-122"/>
+                <a:cs typeface="Calibri" pitchFamily="34" charset="-120"/>
+              </a:rPr>
+              <a:t>It remembers what you tell it — and what it got wrong</a:t>
+            </a:r>
+            <a:endParaRPr lang="en-US" sz="3600" dirty="0"/>
+          </a:p>
+        </p:txBody>
+      </p:sp>
+      <p:graphicFrame>
+        <p:nvGraphicFramePr>
+          <p:cNvPr id="9" name="Table 0"/>
+          <p:cNvGraphicFramePr>
+            <a:graphicFrameLocks noGrp="1"/>
+          </p:cNvGraphicFramePr>
+          <p:nvPr>
+            <p:extLst>
+              <p:ext uri="{D42A27DB-BD31-4B8C-83A1-F6EECF244321}">
+                <p14:modId xmlns:p14="http://schemas.microsoft.com/office/powerpoint/2010/main" val="1579011935"/>
+              </p:ext>
+            </p:extLst>
+          </p:nvPr>
+        </p:nvGraphicFramePr>
+        <p:xfrm>
+          <a:off x="457200" y="1417320"/>
+          <a:ext cx="8229600" cy="914400"/>
+        </p:xfrm>
+        <a:graphic>
+          <a:graphicData uri="http://schemas.openxmlformats.org/drawingml/2006/table">
+            <a:tbl>
+              <a:tblPr/>
+              <a:tblGrid>
+                <a:gridCol w="2286000"/>
+                <a:gridCol w="2971800"/>
+                <a:gridCol w="2971800"/>
+              </a:tblGrid>
+              <a:tr h="0">
+                <a:tc>
+                  <a:txBody>
+                    <a:bodyPr/>
+                    <a:lstStyle/>
+                    <a:p>
+                      <a:pPr algn="l" indent="0" marL="0">
+                        <a:buNone/>
+                      </a:pPr>
+                      <a:endParaRPr lang="en-US" sz="1400" dirty="0">
+                        <a:latin typeface="Calibri" charset="0"/>
+                        <a:ea typeface="Calibri" charset="0"/>
+                        <a:cs typeface="Calibri" charset="0"/>
+                      </a:endParaRPr>
+                    </a:p>
+                  </a:txBody>
+                  <a:tcPr marL="91440" marR="91440" marT="45720" marB="45720">
+                    <a:lnL w="6350" cap="flat" cmpd="sng" algn="ctr">
+                      <a:solidFill>
+                        <a:srgbClr val="D1D5DB"/>
+                      </a:solidFill>
+                      <a:prstDash val="solid"/>
+                      <a:round/>
+                      <a:headEnd type="none" w="med" len="med"/>
+                      <a:tailEnd type="none" w="med" len="med"/>
+                    </a:lnL>
+                    <a:lnR w="6350" cap="flat" cmpd="sng" algn="ctr">
+                      <a:solidFill>
+                        <a:srgbClr val="D1D5DB"/>
+                      </a:solidFill>
+                      <a:prstDash val="solid"/>
+                      <a:round/>
+                      <a:headEnd type="none" w="med" len="med"/>
+                      <a:tailEnd type="none" w="med" len="med"/>
+                    </a:lnR>
+                    <a:lnT w="6350" cap="flat" cmpd="sng" algn="ctr">
+                      <a:solidFill>
+                        <a:srgbClr val="D1D5DB"/>
+                      </a:solidFill>
+                      <a:prstDash val="solid"/>
+                      <a:round/>
+                      <a:headEnd type="none" w="med" len="med"/>
+                      <a:tailEnd type="none" w="med" len="med"/>
+                    </a:lnT>
+                    <a:lnB w="6350" cap="flat" cmpd="sng" algn="ctr">
+                      <a:solidFill>
+                        <a:srgbClr val="D1D5DB"/>
+                      </a:solidFill>
+                      <a:prstDash val="solid"/>
+                      <a:round/>
+                      <a:headEnd type="none" w="med" len="med"/>
+                      <a:tailEnd type="none" w="med" len="med"/>
+                    </a:lnB>
+                    <a:solidFill>
+                      <a:srgbClr val="33E0A8"/>
+                    </a:solidFill>
+                  </a:tcPr>
+                </a:tc>
+                <a:tc>
+                  <a:txBody>
+                    <a:bodyPr/>
+                    <a:lstStyle/>
+                    <a:p>
+                      <a:pPr algn="l" indent="0" marL="0">
+                        <a:buNone/>
+                      </a:pPr>
+                      <a:r>
+                        <a:rPr lang="en-US" sz="1400" b="1" dirty="0">
+                          <a:solidFill>
+                            <a:srgbClr val="FFFFFF"/>
+                          </a:solidFill>
+                          <a:latin typeface="Calibri" pitchFamily="34" charset="0"/>
+                          <a:ea typeface="Calibri" pitchFamily="34" charset="-122"/>
+                          <a:cs typeface="Calibri" pitchFamily="34" charset="-120"/>
+                        </a:rPr>
+                        <a:t>Typical AI coding assistant</a:t>
+                      </a:r>
+                      <a:endParaRPr lang="en-US" sz="1400" dirty="0">
+                        <a:latin typeface="Calibri" charset="0"/>
+                        <a:ea typeface="Calibri" charset="0"/>
+                        <a:cs typeface="Calibri" charset="0"/>
+                      </a:endParaRPr>
+                    </a:p>
+                  </a:txBody>
+                  <a:tcPr marL="91440" marR="91440" marT="45720" marB="45720">
+                    <a:lnL w="6350" cap="flat" cmpd="sng" algn="ctr">
+                      <a:solidFill>
+                        <a:srgbClr val="D1D5DB"/>
+                      </a:solidFill>
+                      <a:prstDash val="solid"/>
+                      <a:round/>
+                      <a:headEnd type="none" w="med" len="med"/>
+                      <a:tailEnd type="none" w="med" len="med"/>
+                    </a:lnL>
+                    <a:lnR w="6350" cap="flat" cmpd="sng" algn="ctr">
+                      <a:solidFill>
+                        <a:srgbClr val="D1D5DB"/>
+                      </a:solidFill>
+                      <a:prstDash val="solid"/>
+                      <a:round/>
+                      <a:headEnd type="none" w="med" len="med"/>
+                      <a:tailEnd type="none" w="med" len="med"/>
+                    </a:lnR>
+                    <a:lnT w="6350" cap="flat" cmpd="sng" algn="ctr">
+                      <a:solidFill>
+                        <a:srgbClr val="D1D5DB"/>
+                      </a:solidFill>
+                      <a:prstDash val="solid"/>
+                      <a:round/>
+                      <a:headEnd type="none" w="med" len="med"/>
+                      <a:tailEnd type="none" w="med" len="med"/>
+                    </a:lnT>
+                    <a:lnB w="6350" cap="flat" cmpd="sng" algn="ctr">
+                      <a:solidFill>
+                        <a:srgbClr val="D1D5DB"/>
+                      </a:solidFill>
+                      <a:prstDash val="solid"/>
+                      <a:round/>
+                      <a:headEnd type="none" w="med" len="med"/>
+                      <a:tailEnd type="none" w="med" len="med"/>
+                    </a:lnB>
+                    <a:solidFill>
+                      <a:srgbClr val="33E0A8"/>
+                    </a:solidFill>
+                  </a:tcPr>
+                </a:tc>
+                <a:tc>
+                  <a:txBody>
+                    <a:bodyPr/>
+                    <a:lstStyle/>
+                    <a:p>
+                      <a:pPr algn="l" indent="0" marL="0">
+                        <a:buNone/>
+                      </a:pPr>
+                      <a:r>
+                        <a:rPr lang="en-US" sz="1400" b="1" dirty="0">
+                          <a:solidFill>
+                            <a:srgbClr val="FFFFFF"/>
+                          </a:solidFill>
+                          <a:latin typeface="Calibri" pitchFamily="34" charset="0"/>
+                          <a:ea typeface="Calibri" pitchFamily="34" charset="-122"/>
+                          <a:cs typeface="Calibri" pitchFamily="34" charset="-120"/>
+                        </a:rPr>
+                        <a:t>Wrexlyn</a:t>
+                      </a:r>
+                      <a:endParaRPr lang="en-US" sz="1400" dirty="0">
+                        <a:latin typeface="Calibri" charset="0"/>
+                        <a:ea typeface="Calibri" charset="0"/>
+                        <a:cs typeface="Calibri" charset="0"/>
+                      </a:endParaRPr>
+                    </a:p>
+                  </a:txBody>
+                  <a:tcPr marL="91440" marR="91440" marT="45720" marB="45720">
+                    <a:lnL w="6350" cap="flat" cmpd="sng" algn="ctr">
+                      <a:solidFill>
+                        <a:srgbClr val="D1D5DB"/>
+                      </a:solidFill>
+                      <a:prstDash val="solid"/>
+                      <a:round/>
+                      <a:headEnd type="none" w="med" len="med"/>
+                      <a:tailEnd type="none" w="med" len="med"/>
+                    </a:lnL>
+                    <a:lnR w="6350" cap="flat" cmpd="sng" algn="ctr">
+                      <a:solidFill>
+                        <a:srgbClr val="D1D5DB"/>
+                      </a:solidFill>
+                      <a:prstDash val="solid"/>
+                      <a:round/>
+                      <a:headEnd type="none" w="med" len="med"/>
+                      <a:tailEnd type="none" w="med" len="med"/>
+                    </a:lnR>
+                    <a:lnT w="6350" cap="flat" cmpd="sng" algn="ctr">
+                      <a:solidFill>
+                        <a:srgbClr val="D1D5DB"/>
+                      </a:solidFill>
+                      <a:prstDash val="solid"/>
+                      <a:round/>
+                      <a:headEnd type="none" w="med" len="med"/>
+                      <a:tailEnd type="none" w="med" len="med"/>
+                    </a:lnT>
+                    <a:lnB w="6350" cap="flat" cmpd="sng" algn="ctr">
+                      <a:solidFill>
+                        <a:srgbClr val="D1D5DB"/>
+                      </a:solidFill>
+                      <a:prstDash val="solid"/>
+                      <a:round/>
+                      <a:headEnd type="none" w="med" len="med"/>
+                      <a:tailEnd type="none" w="med" len="med"/>
+                    </a:lnB>
+                    <a:solidFill>
+                      <a:srgbClr val="33E0A8"/>
+                    </a:solidFill>
+                  </a:tcPr>
+                </a:tc>
+              </a:tr>
+              <a:tr h="0">
+                <a:tc>
+                  <a:txBody>
+                    <a:bodyPr/>
+                    <a:lstStyle/>
+                    <a:p>
+                      <a:pPr algn="l" indent="0" marL="0">
+                        <a:buNone/>
+                      </a:pPr>
+                      <a:r>
+                        <a:rPr lang="en-US" sz="1400" dirty="0">
+                          <a:solidFill>
+                            <a:srgbClr val="000000"/>
+                          </a:solidFill>
+                          <a:latin typeface="Calibri" pitchFamily="34" charset="0"/>
+                          <a:ea typeface="Calibri" pitchFamily="34" charset="-122"/>
+                          <a:cs typeface="Calibri" pitchFamily="34" charset="-120"/>
+                        </a:rPr>
+                        <a:t>You state a preference</a:t>
+                      </a:r>
+                      <a:endParaRPr lang="en-US" sz="1400" dirty="0">
+                        <a:latin typeface="Calibri" charset="0"/>
+                        <a:ea typeface="Calibri" charset="0"/>
+                        <a:cs typeface="Calibri" charset="0"/>
+                      </a:endParaRPr>
+                    </a:p>
+                  </a:txBody>
+                  <a:tcPr marL="91440" marR="91440" marT="45720" marB="45720">
+                    <a:lnL w="6350" cap="flat" cmpd="sng" algn="ctr">
+                      <a:solidFill>
+                        <a:srgbClr val="D1D5DB"/>
+                      </a:solidFill>
+                      <a:prstDash val="solid"/>
+                      <a:round/>
+                      <a:headEnd type="none" w="med" len="med"/>
+                      <a:tailEnd type="none" w="med" len="med"/>
+                    </a:lnL>
+                    <a:lnR w="6350" cap="flat" cmpd="sng" algn="ctr">
+                      <a:solidFill>
+                        <a:srgbClr val="D1D5DB"/>
+                      </a:solidFill>
+                      <a:prstDash val="solid"/>
+                      <a:round/>
+                      <a:headEnd type="none" w="med" len="med"/>
+                      <a:tailEnd type="none" w="med" len="med"/>
+                    </a:lnR>
+                    <a:lnT w="6350" cap="flat" cmpd="sng" algn="ctr">
+                      <a:solidFill>
+                        <a:srgbClr val="D1D5DB"/>
+                      </a:solidFill>
+                      <a:prstDash val="solid"/>
+                      <a:round/>
+                      <a:headEnd type="none" w="med" len="med"/>
+                      <a:tailEnd type="none" w="med" len="med"/>
+                    </a:lnT>
+                    <a:lnB w="6350" cap="flat" cmpd="sng" algn="ctr">
+                      <a:solidFill>
+                        <a:srgbClr val="D1D5DB"/>
+                      </a:solidFill>
+                      <a:prstDash val="solid"/>
+                      <a:round/>
+                      <a:headEnd type="none" w="med" len="med"/>
+                      <a:tailEnd type="none" w="med" len="med"/>
+                    </a:lnB>
+                  </a:tcPr>
+                </a:tc>
+                <a:tc>
+                  <a:txBody>
+                    <a:bodyPr/>
+                    <a:lstStyle/>
+                    <a:p>
+                      <a:pPr algn="l" indent="0" marL="0">
+                        <a:buNone/>
+                      </a:pPr>
+                      <a:r>
+                        <a:rPr lang="en-US" sz="1400" dirty="0">
+                          <a:solidFill>
+                            <a:srgbClr val="000000"/>
+                          </a:solidFill>
+                          <a:latin typeface="Calibri" pitchFamily="34" charset="0"/>
+                          <a:ea typeface="Calibri" pitchFamily="34" charset="-122"/>
+                          <a:cs typeface="Calibri" pitchFamily="34" charset="-120"/>
+                        </a:rPr>
+                        <a:t>Applies this turn, forgotten next session</a:t>
+                      </a:r>
+                      <a:endParaRPr lang="en-US" sz="1400" dirty="0">
+                        <a:latin typeface="Calibri" charset="0"/>
+                        <a:ea typeface="Calibri" charset="0"/>
+                        <a:cs typeface="Calibri" charset="0"/>
+                      </a:endParaRPr>
+                    </a:p>
+                  </a:txBody>
+                  <a:tcPr marL="91440" marR="91440" marT="45720" marB="45720">
+                    <a:lnL w="6350" cap="flat" cmpd="sng" algn="ctr">
+                      <a:solidFill>
+                        <a:srgbClr val="D1D5DB"/>
+                      </a:solidFill>
+                      <a:prstDash val="solid"/>
+                      <a:round/>
+                      <a:headEnd type="none" w="med" len="med"/>
+                      <a:tailEnd type="none" w="med" len="med"/>
+                    </a:lnL>
+                    <a:lnR w="6350" cap="flat" cmpd="sng" algn="ctr">
+                      <a:solidFill>
+                        <a:srgbClr val="D1D5DB"/>
+                      </a:solidFill>
+                      <a:prstDash val="solid"/>
+                      <a:round/>
+                      <a:headEnd type="none" w="med" len="med"/>
+                      <a:tailEnd type="none" w="med" len="med"/>
+                    </a:lnR>
+                    <a:lnT w="6350" cap="flat" cmpd="sng" algn="ctr">
+                      <a:solidFill>
+                        <a:srgbClr val="D1D5DB"/>
+                      </a:solidFill>
+                      <a:prstDash val="solid"/>
+                      <a:round/>
+                      <a:headEnd type="none" w="med" len="med"/>
+                      <a:tailEnd type="none" w="med" len="med"/>
+                    </a:lnT>
+                    <a:lnB w="6350" cap="flat" cmpd="sng" algn="ctr">
+                      <a:solidFill>
+                        <a:srgbClr val="D1D5DB"/>
+                      </a:solidFill>
+                      <a:prstDash val="solid"/>
+                      <a:round/>
+                      <a:headEnd type="none" w="med" len="med"/>
+                      <a:tailEnd type="none" w="med" len="med"/>
+                    </a:lnB>
+                  </a:tcPr>
+                </a:tc>
+                <a:tc>
+                  <a:txBody>
+                    <a:bodyPr/>
+                    <a:lstStyle/>
+                    <a:p>
+                      <a:pPr algn="l" indent="0" marL="0">
+                        <a:buNone/>
+                      </a:pPr>
+                      <a:r>
+                        <a:rPr lang="en-US" sz="1400" dirty="0">
+                          <a:solidFill>
+                            <a:srgbClr val="000000"/>
+                          </a:solidFill>
+                          <a:latin typeface="Calibri" pitchFamily="34" charset="0"/>
+                          <a:ea typeface="Calibri" pitchFamily="34" charset="-122"/>
+                          <a:cs typeface="Calibri" pitchFamily="34" charset="-120"/>
+                        </a:rPr>
+                        <a:t>Saved via remember_preference — applies from now on</a:t>
+                      </a:r>
+                      <a:endParaRPr lang="en-US" sz="1400" dirty="0">
+                        <a:latin typeface="Calibri" charset="0"/>
+                        <a:ea typeface="Calibri" charset="0"/>
+                        <a:cs typeface="Calibri" charset="0"/>
+                      </a:endParaRPr>
+                    </a:p>
+                  </a:txBody>
+                  <a:tcPr marL="91440" marR="91440" marT="45720" marB="45720">
+                    <a:lnL w="6350" cap="flat" cmpd="sng" algn="ctr">
+                      <a:solidFill>
+                        <a:srgbClr val="D1D5DB"/>
+                      </a:solidFill>
+                      <a:prstDash val="solid"/>
+                      <a:round/>
+                      <a:headEnd type="none" w="med" len="med"/>
+                      <a:tailEnd type="none" w="med" len="med"/>
+                    </a:lnL>
+                    <a:lnR w="6350" cap="flat" cmpd="sng" algn="ctr">
+                      <a:solidFill>
+                        <a:srgbClr val="D1D5DB"/>
+                      </a:solidFill>
+                      <a:prstDash val="solid"/>
+                      <a:round/>
+                      <a:headEnd type="none" w="med" len="med"/>
+                      <a:tailEnd type="none" w="med" len="med"/>
+                    </a:lnR>
+                    <a:lnT w="6350" cap="flat" cmpd="sng" algn="ctr">
+                      <a:solidFill>
+                        <a:srgbClr val="D1D5DB"/>
+                      </a:solidFill>
+                      <a:prstDash val="solid"/>
+                      <a:round/>
+                      <a:headEnd type="none" w="med" len="med"/>
+                      <a:tailEnd type="none" w="med" len="med"/>
+                    </a:lnT>
+                    <a:lnB w="6350" cap="flat" cmpd="sng" algn="ctr">
+                      <a:solidFill>
+                        <a:srgbClr val="D1D5DB"/>
+                      </a:solidFill>
+                      <a:prstDash val="solid"/>
+                      <a:round/>
+                      <a:headEnd type="none" w="med" len="med"/>
+                      <a:tailEnd type="none" w="med" len="med"/>
+                    </a:lnB>
+                  </a:tcPr>
+                </a:tc>
+              </a:tr>
+              <a:tr h="0">
+                <a:tc>
+                  <a:txBody>
+                    <a:bodyPr/>
+                    <a:lstStyle/>
+                    <a:p>
+                      <a:pPr algn="l" indent="0" marL="0">
+                        <a:buNone/>
+                      </a:pPr>
+                      <a:r>
+                        <a:rPr lang="en-US" sz="1400" dirty="0">
+                          <a:solidFill>
+                            <a:srgbClr val="000000"/>
+                          </a:solidFill>
+                          <a:latin typeface="Calibri" pitchFamily="34" charset="0"/>
+                          <a:ea typeface="Calibri" pitchFamily="34" charset="-122"/>
+                          <a:cs typeface="Calibri" pitchFamily="34" charset="-120"/>
+                        </a:rPr>
+                        <a:t>It finishes a multi-step task</a:t>
+                      </a:r>
+                      <a:endParaRPr lang="en-US" sz="1400" dirty="0">
+                        <a:latin typeface="Calibri" charset="0"/>
+                        <a:ea typeface="Calibri" charset="0"/>
+                        <a:cs typeface="Calibri" charset="0"/>
+                      </a:endParaRPr>
+                    </a:p>
+                  </a:txBody>
+                  <a:tcPr marL="91440" marR="91440" marT="45720" marB="45720">
+                    <a:lnL w="6350" cap="flat" cmpd="sng" algn="ctr">
+                      <a:solidFill>
+                        <a:srgbClr val="D1D5DB"/>
+                      </a:solidFill>
+                      <a:prstDash val="solid"/>
+                      <a:round/>
+                      <a:headEnd type="none" w="med" len="med"/>
+                      <a:tailEnd type="none" w="med" len="med"/>
+                    </a:lnL>
+                    <a:lnR w="6350" cap="flat" cmpd="sng" algn="ctr">
+                      <a:solidFill>
+                        <a:srgbClr val="D1D5DB"/>
+                      </a:solidFill>
+                      <a:prstDash val="solid"/>
+                      <a:round/>
+                      <a:headEnd type="none" w="med" len="med"/>
+                      <a:tailEnd type="none" w="med" len="med"/>
+                    </a:lnR>
+                    <a:lnT w="6350" cap="flat" cmpd="sng" algn="ctr">
+                      <a:solidFill>
+                        <a:srgbClr val="D1D5DB"/>
+                      </a:solidFill>
+                      <a:prstDash val="solid"/>
+                      <a:round/>
+                      <a:headEnd type="none" w="med" len="med"/>
+                      <a:tailEnd type="none" w="med" len="med"/>
+                    </a:lnT>
+                    <a:lnB w="6350" cap="flat" cmpd="sng" algn="ctr">
+                      <a:solidFill>
+                        <a:srgbClr val="D1D5DB"/>
+                      </a:solidFill>
+                      <a:prstDash val="solid"/>
+                      <a:round/>
+                      <a:headEnd type="none" w="med" len="med"/>
+                      <a:tailEnd type="none" w="med" len="med"/>
+                    </a:lnB>
+                    <a:solidFill>
+                      <a:srgbClr val="F3F4F6"/>
+                    </a:solidFill>
+                  </a:tcPr>
+                </a:tc>
+                <a:tc>
+                  <a:txBody>
+                    <a:bodyPr/>
+                    <a:lstStyle/>
+                    <a:p>
+                      <a:pPr algn="l" indent="0" marL="0">
+                        <a:buNone/>
+                      </a:pPr>
+                      <a:r>
+                        <a:rPr lang="en-US" sz="1400" dirty="0">
+                          <a:solidFill>
+                            <a:srgbClr val="000000"/>
+                          </a:solidFill>
+                          <a:latin typeface="Calibri" pitchFamily="34" charset="0"/>
+                          <a:ea typeface="Calibri" pitchFamily="34" charset="-122"/>
+                          <a:cs typeface="Calibri" pitchFamily="34" charset="-120"/>
+                        </a:rPr>
+                        <a:t>Re-derives it from scratch next time</a:t>
+                      </a:r>
+                      <a:endParaRPr lang="en-US" sz="1400" dirty="0">
+                        <a:latin typeface="Calibri" charset="0"/>
+                        <a:ea typeface="Calibri" charset="0"/>
+                        <a:cs typeface="Calibri" charset="0"/>
+                      </a:endParaRPr>
+                    </a:p>
+                  </a:txBody>
+                  <a:tcPr marL="91440" marR="91440" marT="45720" marB="45720">
+                    <a:lnL w="6350" cap="flat" cmpd="sng" algn="ctr">
+                      <a:solidFill>
+                        <a:srgbClr val="D1D5DB"/>
+                      </a:solidFill>
+                      <a:prstDash val="solid"/>
+                      <a:round/>
+                      <a:headEnd type="none" w="med" len="med"/>
+                      <a:tailEnd type="none" w="med" len="med"/>
+                    </a:lnL>
+                    <a:lnR w="6350" cap="flat" cmpd="sng" algn="ctr">
+                      <a:solidFill>
+                        <a:srgbClr val="D1D5DB"/>
+                      </a:solidFill>
+                      <a:prstDash val="solid"/>
+                      <a:round/>
+                      <a:headEnd type="none" w="med" len="med"/>
+                      <a:tailEnd type="none" w="med" len="med"/>
+                    </a:lnR>
+                    <a:lnT w="6350" cap="flat" cmpd="sng" algn="ctr">
+                      <a:solidFill>
+                        <a:srgbClr val="D1D5DB"/>
+                      </a:solidFill>
+                      <a:prstDash val="solid"/>
+                      <a:round/>
+                      <a:headEnd type="none" w="med" len="med"/>
+                      <a:tailEnd type="none" w="med" len="med"/>
+                    </a:lnT>
+                    <a:lnB w="6350" cap="flat" cmpd="sng" algn="ctr">
+                      <a:solidFill>
+                        <a:srgbClr val="D1D5DB"/>
+                      </a:solidFill>
+                      <a:prstDash val="solid"/>
+                      <a:round/>
+                      <a:headEnd type="none" w="med" len="med"/>
+                      <a:tailEnd type="none" w="med" len="med"/>
+                    </a:lnB>
+                    <a:solidFill>
+                      <a:srgbClr val="F3F4F6"/>
+                    </a:solidFill>
+                  </a:tcPr>
+                </a:tc>
+                <a:tc>
+                  <a:txBody>
+                    <a:bodyPr/>
+                    <a:lstStyle/>
+                    <a:p>
+                      <a:pPr algn="l" indent="0" marL="0">
+                        <a:buNone/>
+                      </a:pPr>
+                      <a:r>
+                        <a:rPr lang="en-US" sz="1400" dirty="0">
+                          <a:solidFill>
+                            <a:srgbClr val="000000"/>
+                          </a:solidFill>
+                          <a:latin typeface="Calibri" pitchFamily="34" charset="0"/>
+                          <a:ea typeface="Calibri" pitchFamily="34" charset="-122"/>
+                          <a:cs typeface="Calibri" pitchFamily="34" charset="-120"/>
+                        </a:rPr>
+                        <a:t>save_skill / recall_skill bring it back on demand</a:t>
+                      </a:r>
+                      <a:endParaRPr lang="en-US" sz="1400" dirty="0">
+                        <a:latin typeface="Calibri" charset="0"/>
+                        <a:ea typeface="Calibri" charset="0"/>
+                        <a:cs typeface="Calibri" charset="0"/>
+                      </a:endParaRPr>
+                    </a:p>
+                  </a:txBody>
+                  <a:tcPr marL="91440" marR="91440" marT="45720" marB="45720">
+                    <a:lnL w="6350" cap="flat" cmpd="sng" algn="ctr">
+                      <a:solidFill>
+                        <a:srgbClr val="D1D5DB"/>
+                      </a:solidFill>
+                      <a:prstDash val="solid"/>
+                      <a:round/>
+                      <a:headEnd type="none" w="med" len="med"/>
+                      <a:tailEnd type="none" w="med" len="med"/>
+                    </a:lnL>
+                    <a:lnR w="6350" cap="flat" cmpd="sng" algn="ctr">
+                      <a:solidFill>
+                        <a:srgbClr val="D1D5DB"/>
+                      </a:solidFill>
+                      <a:prstDash val="solid"/>
+                      <a:round/>
+                      <a:headEnd type="none" w="med" len="med"/>
+                      <a:tailEnd type="none" w="med" len="med"/>
+                    </a:lnR>
+                    <a:lnT w="6350" cap="flat" cmpd="sng" algn="ctr">
+                      <a:solidFill>
+                        <a:srgbClr val="D1D5DB"/>
+                      </a:solidFill>
+                      <a:prstDash val="solid"/>
+                      <a:round/>
+                      <a:headEnd type="none" w="med" len="med"/>
+                      <a:tailEnd type="none" w="med" len="med"/>
+                    </a:lnT>
+                    <a:lnB w="6350" cap="flat" cmpd="sng" algn="ctr">
+                      <a:solidFill>
+                        <a:srgbClr val="D1D5DB"/>
+                      </a:solidFill>
+                      <a:prstDash val="solid"/>
+                      <a:round/>
+                      <a:headEnd type="none" w="med" len="med"/>
+                      <a:tailEnd type="none" w="med" len="med"/>
+                    </a:lnB>
+                    <a:solidFill>
+                      <a:srgbClr val="F3F4F6"/>
+                    </a:solidFill>
+                  </a:tcPr>
+                </a:tc>
+              </a:tr>
+              <a:tr h="0">
+                <a:tc>
+                  <a:txBody>
+                    <a:bodyPr/>
+                    <a:lstStyle/>
+                    <a:p>
+                      <a:pPr algn="l" indent="0" marL="0">
+                        <a:buNone/>
+                      </a:pPr>
+                      <a:r>
+                        <a:rPr lang="en-US" sz="1400" dirty="0">
+                          <a:solidFill>
+                            <a:srgbClr val="000000"/>
+                          </a:solidFill>
+                          <a:latin typeface="Calibri" pitchFamily="34" charset="0"/>
+                          <a:ea typeface="Calibri" pitchFamily="34" charset="-122"/>
+                          <a:cs typeface="Calibri" pitchFamily="34" charset="-120"/>
+                        </a:rPr>
+                        <a:t>When it takes effect</a:t>
+                      </a:r>
+                      <a:endParaRPr lang="en-US" sz="1400" dirty="0">
+                        <a:latin typeface="Calibri" charset="0"/>
+                        <a:ea typeface="Calibri" charset="0"/>
+                        <a:cs typeface="Calibri" charset="0"/>
+                      </a:endParaRPr>
+                    </a:p>
+                  </a:txBody>
+                  <a:tcPr marL="91440" marR="91440" marT="45720" marB="45720">
+                    <a:lnL w="6350" cap="flat" cmpd="sng" algn="ctr">
+                      <a:solidFill>
+                        <a:srgbClr val="D1D5DB"/>
+                      </a:solidFill>
+                      <a:prstDash val="solid"/>
+                      <a:round/>
+                      <a:headEnd type="none" w="med" len="med"/>
+                      <a:tailEnd type="none" w="med" len="med"/>
+                    </a:lnL>
+                    <a:lnR w="6350" cap="flat" cmpd="sng" algn="ctr">
+                      <a:solidFill>
+                        <a:srgbClr val="D1D5DB"/>
+                      </a:solidFill>
+                      <a:prstDash val="solid"/>
+                      <a:round/>
+                      <a:headEnd type="none" w="med" len="med"/>
+                      <a:tailEnd type="none" w="med" len="med"/>
+                    </a:lnR>
+                    <a:lnT w="6350" cap="flat" cmpd="sng" algn="ctr">
+                      <a:solidFill>
+                        <a:srgbClr val="D1D5DB"/>
+                      </a:solidFill>
+                      <a:prstDash val="solid"/>
+                      <a:round/>
+                      <a:headEnd type="none" w="med" len="med"/>
+                      <a:tailEnd type="none" w="med" len="med"/>
+                    </a:lnT>
+                    <a:lnB w="6350" cap="flat" cmpd="sng" algn="ctr">
+                      <a:solidFill>
+                        <a:srgbClr val="D1D5DB"/>
+                      </a:solidFill>
+                      <a:prstDash val="solid"/>
+                      <a:round/>
+                      <a:headEnd type="none" w="med" len="med"/>
+                      <a:tailEnd type="none" w="med" len="med"/>
+                    </a:lnB>
+                  </a:tcPr>
+                </a:tc>
+                <a:tc>
+                  <a:txBody>
+                    <a:bodyPr/>
+                    <a:lstStyle/>
+                    <a:p>
+                      <a:pPr algn="l" indent="0" marL="0">
+                        <a:buNone/>
+                      </a:pPr>
+                      <a:r>
+                        <a:rPr lang="en-US" sz="1400" dirty="0">
+                          <a:solidFill>
+                            <a:srgbClr val="000000"/>
+                          </a:solidFill>
+                          <a:latin typeface="Calibri" pitchFamily="34" charset="0"/>
+                          <a:ea typeface="Calibri" pitchFamily="34" charset="-122"/>
+                          <a:cs typeface="Calibri" pitchFamily="34" charset="-120"/>
+                        </a:rPr>
+                        <a:t>Next session, if at all</a:t>
+                      </a:r>
+                      <a:endParaRPr lang="en-US" sz="1400" dirty="0">
+                        <a:latin typeface="Calibri" charset="0"/>
+                        <a:ea typeface="Calibri" charset="0"/>
+                        <a:cs typeface="Calibri" charset="0"/>
+                      </a:endParaRPr>
+                    </a:p>
+                  </a:txBody>
+                  <a:tcPr marL="91440" marR="91440" marT="45720" marB="45720">
+                    <a:lnL w="6350" cap="flat" cmpd="sng" algn="ctr">
+                      <a:solidFill>
+                        <a:srgbClr val="D1D5DB"/>
+                      </a:solidFill>
+                      <a:prstDash val="solid"/>
+                      <a:round/>
+                      <a:headEnd type="none" w="med" len="med"/>
+                      <a:tailEnd type="none" w="med" len="med"/>
+                    </a:lnL>
+                    <a:lnR w="6350" cap="flat" cmpd="sng" algn="ctr">
+                      <a:solidFill>
+                        <a:srgbClr val="D1D5DB"/>
+                      </a:solidFill>
+                      <a:prstDash val="solid"/>
+                      <a:round/>
+                      <a:headEnd type="none" w="med" len="med"/>
+                      <a:tailEnd type="none" w="med" len="med"/>
+                    </a:lnR>
+                    <a:lnT w="6350" cap="flat" cmpd="sng" algn="ctr">
+                      <a:solidFill>
+                        <a:srgbClr val="D1D5DB"/>
+                      </a:solidFill>
+                      <a:prstDash val="solid"/>
+                      <a:round/>
+                      <a:headEnd type="none" w="med" len="med"/>
+                      <a:tailEnd type="none" w="med" len="med"/>
+                    </a:lnT>
+                    <a:lnB w="6350" cap="flat" cmpd="sng" algn="ctr">
+                      <a:solidFill>
+                        <a:srgbClr val="D1D5DB"/>
+                      </a:solidFill>
+                      <a:prstDash val="solid"/>
+                      <a:round/>
+                      <a:headEnd type="none" w="med" len="med"/>
+                      <a:tailEnd type="none" w="med" len="med"/>
+                    </a:lnB>
+                  </a:tcPr>
+                </a:tc>
+                <a:tc>
+                  <a:txBody>
+                    <a:bodyPr/>
+                    <a:lstStyle/>
+                    <a:p>
+                      <a:pPr algn="l" indent="0" marL="0">
+                        <a:buNone/>
+                      </a:pPr>
+                      <a:r>
+                        <a:rPr lang="en-US" sz="1400" dirty="0">
+                          <a:solidFill>
+                            <a:srgbClr val="000000"/>
+                          </a:solidFill>
+                          <a:latin typeface="Calibri" pitchFamily="34" charset="0"/>
+                          <a:ea typeface="Calibri" pitchFamily="34" charset="-122"/>
+                          <a:cs typeface="Calibri" pitchFamily="34" charset="-120"/>
+                        </a:rPr>
+                        <a:t>Immediately — mid-session</a:t>
+                      </a:r>
+                      <a:endParaRPr lang="en-US" sz="1400" dirty="0">
+                        <a:latin typeface="Calibri" charset="0"/>
+                        <a:ea typeface="Calibri" charset="0"/>
+                        <a:cs typeface="Calibri" charset="0"/>
+                      </a:endParaRPr>
+                    </a:p>
+                  </a:txBody>
+                  <a:tcPr marL="91440" marR="91440" marT="45720" marB="45720">
+                    <a:lnL w="6350" cap="flat" cmpd="sng" algn="ctr">
+                      <a:solidFill>
+                        <a:srgbClr val="D1D5DB"/>
+                      </a:solidFill>
+                      <a:prstDash val="solid"/>
+                      <a:round/>
+                      <a:headEnd type="none" w="med" len="med"/>
+                      <a:tailEnd type="none" w="med" len="med"/>
+                    </a:lnL>
+                    <a:lnR w="6350" cap="flat" cmpd="sng" algn="ctr">
+                      <a:solidFill>
+                        <a:srgbClr val="D1D5DB"/>
+                      </a:solidFill>
+                      <a:prstDash val="solid"/>
+                      <a:round/>
+                      <a:headEnd type="none" w="med" len="med"/>
+                      <a:tailEnd type="none" w="med" len="med"/>
+                    </a:lnR>
+                    <a:lnT w="6350" cap="flat" cmpd="sng" algn="ctr">
+                      <a:solidFill>
+                        <a:srgbClr val="D1D5DB"/>
+                      </a:solidFill>
+                      <a:prstDash val="solid"/>
+                      <a:round/>
+                      <a:headEnd type="none" w="med" len="med"/>
+                      <a:tailEnd type="none" w="med" len="med"/>
+                    </a:lnT>
+                    <a:lnB w="6350" cap="flat" cmpd="sng" algn="ctr">
+                      <a:solidFill>
+                        <a:srgbClr val="D1D5DB"/>
+                      </a:solidFill>
+                      <a:prstDash val="solid"/>
+                      <a:round/>
+                      <a:headEnd type="none" w="med" len="med"/>
+                      <a:tailEnd type="none" w="med" len="med"/>
+                    </a:lnB>
+                  </a:tcPr>
+                </a:tc>
+              </a:tr>
+            </a:tbl>
+          </a:graphicData>
+        </a:graphic>
+      </p:graphicFrame>
+    </p:spTree>
+  </p:cSld>
+  <p:clrMapOvr>
+    <a:masterClrMapping/>
+  </p:clrMapOvr>
+</p:sld>
+</file>
+
 <file path=ppt/slides/slide2.xml><?xml version="1.0" encoding="utf-8"?>
 <p:sld xmlns:a="http://schemas.openxmlformats.org/drawingml/2006/main" xmlns:r="http://schemas.openxmlformats.org/officeDocument/2006/relationships" xmlns:p="http://schemas.openxmlformats.org/presentationml/2006/main">
   <p:cSld name="Slide 2">
@@ -8273,6 +9171,268 @@
                           <a:ea typeface="Calibri" pitchFamily="34" charset="-122"/>
                           <a:cs typeface="Calibri" pitchFamily="34" charset="-120"/>
                         </a:rPr>
+                        <a:t>Learns your preferences</a:t>
+                      </a:r>
+                      <a:endParaRPr lang="en-US" sz="1400" dirty="0">
+                        <a:latin typeface="Calibri" charset="0"/>
+                        <a:ea typeface="Calibri" charset="0"/>
+                        <a:cs typeface="Calibri" charset="0"/>
+                      </a:endParaRPr>
+                    </a:p>
+                  </a:txBody>
+                  <a:tcPr marL="91440" marR="91440" marT="45720" marB="45720">
+                    <a:lnL w="6350" cap="flat" cmpd="sng" algn="ctr">
+                      <a:solidFill>
+                        <a:srgbClr val="D1D5DB"/>
+                      </a:solidFill>
+                      <a:prstDash val="solid"/>
+                      <a:round/>
+                      <a:headEnd type="none" w="med" len="med"/>
+                      <a:tailEnd type="none" w="med" len="med"/>
+                    </a:lnL>
+                    <a:lnR w="6350" cap="flat" cmpd="sng" algn="ctr">
+                      <a:solidFill>
+                        <a:srgbClr val="D1D5DB"/>
+                      </a:solidFill>
+                      <a:prstDash val="solid"/>
+                      <a:round/>
+                      <a:headEnd type="none" w="med" len="med"/>
+                      <a:tailEnd type="none" w="med" len="med"/>
+                    </a:lnR>
+                    <a:lnT w="6350" cap="flat" cmpd="sng" algn="ctr">
+                      <a:solidFill>
+                        <a:srgbClr val="D1D5DB"/>
+                      </a:solidFill>
+                      <a:prstDash val="solid"/>
+                      <a:round/>
+                      <a:headEnd type="none" w="med" len="med"/>
+                      <a:tailEnd type="none" w="med" len="med"/>
+                    </a:lnT>
+                    <a:lnB w="6350" cap="flat" cmpd="sng" algn="ctr">
+                      <a:solidFill>
+                        <a:srgbClr val="D1D5DB"/>
+                      </a:solidFill>
+                      <a:prstDash val="solid"/>
+                      <a:round/>
+                      <a:headEnd type="none" w="med" len="med"/>
+                      <a:tailEnd type="none" w="med" len="med"/>
+                    </a:lnB>
+                  </a:tcPr>
+                </a:tc>
+                <a:tc>
+                  <a:txBody>
+                    <a:bodyPr/>
+                    <a:lstStyle/>
+                    <a:p>
+                      <a:pPr algn="l" indent="0" marL="0">
+                        <a:buNone/>
+                      </a:pPr>
+                      <a:r>
+                        <a:rPr lang="en-US" sz="1400" dirty="0">
+                          <a:solidFill>
+                            <a:srgbClr val="000000"/>
+                          </a:solidFill>
+                          <a:latin typeface="Calibri" pitchFamily="34" charset="0"/>
+                          <a:ea typeface="Calibri" pitchFamily="34" charset="-122"/>
+                          <a:cs typeface="Calibri" pitchFamily="34" charset="-120"/>
+                        </a:rPr>
+                        <a:t>No — resets every session</a:t>
+                      </a:r>
+                      <a:endParaRPr lang="en-US" sz="1400" dirty="0">
+                        <a:latin typeface="Calibri" charset="0"/>
+                        <a:ea typeface="Calibri" charset="0"/>
+                        <a:cs typeface="Calibri" charset="0"/>
+                      </a:endParaRPr>
+                    </a:p>
+                  </a:txBody>
+                  <a:tcPr marL="91440" marR="91440" marT="45720" marB="45720">
+                    <a:lnL w="6350" cap="flat" cmpd="sng" algn="ctr">
+                      <a:solidFill>
+                        <a:srgbClr val="D1D5DB"/>
+                      </a:solidFill>
+                      <a:prstDash val="solid"/>
+                      <a:round/>
+                      <a:headEnd type="none" w="med" len="med"/>
+                      <a:tailEnd type="none" w="med" len="med"/>
+                    </a:lnL>
+                    <a:lnR w="6350" cap="flat" cmpd="sng" algn="ctr">
+                      <a:solidFill>
+                        <a:srgbClr val="D1D5DB"/>
+                      </a:solidFill>
+                      <a:prstDash val="solid"/>
+                      <a:round/>
+                      <a:headEnd type="none" w="med" len="med"/>
+                      <a:tailEnd type="none" w="med" len="med"/>
+                    </a:lnR>
+                    <a:lnT w="6350" cap="flat" cmpd="sng" algn="ctr">
+                      <a:solidFill>
+                        <a:srgbClr val="D1D5DB"/>
+                      </a:solidFill>
+                      <a:prstDash val="solid"/>
+                      <a:round/>
+                      <a:headEnd type="none" w="med" len="med"/>
+                      <a:tailEnd type="none" w="med" len="med"/>
+                    </a:lnT>
+                    <a:lnB w="6350" cap="flat" cmpd="sng" algn="ctr">
+                      <a:solidFill>
+                        <a:srgbClr val="D1D5DB"/>
+                      </a:solidFill>
+                      <a:prstDash val="solid"/>
+                      <a:round/>
+                      <a:headEnd type="none" w="med" len="med"/>
+                      <a:tailEnd type="none" w="med" len="med"/>
+                    </a:lnB>
+                  </a:tcPr>
+                </a:tc>
+                <a:tc>
+                  <a:txBody>
+                    <a:bodyPr/>
+                    <a:lstStyle/>
+                    <a:p>
+                      <a:pPr algn="l" indent="0" marL="0">
+                        <a:buNone/>
+                      </a:pPr>
+                      <a:r>
+                        <a:rPr lang="en-US" sz="1400" dirty="0">
+                          <a:solidFill>
+                            <a:srgbClr val="000000"/>
+                          </a:solidFill>
+                          <a:latin typeface="Calibri" pitchFamily="34" charset="0"/>
+                          <a:ea typeface="Calibri" pitchFamily="34" charset="-122"/>
+                          <a:cs typeface="Calibri" pitchFamily="34" charset="-120"/>
+                        </a:rPr>
+                        <a:t>No</a:t>
+                      </a:r>
+                      <a:endParaRPr lang="en-US" sz="1400" dirty="0">
+                        <a:latin typeface="Calibri" charset="0"/>
+                        <a:ea typeface="Calibri" charset="0"/>
+                        <a:cs typeface="Calibri" charset="0"/>
+                      </a:endParaRPr>
+                    </a:p>
+                  </a:txBody>
+                  <a:tcPr marL="91440" marR="91440" marT="45720" marB="45720">
+                    <a:lnL w="6350" cap="flat" cmpd="sng" algn="ctr">
+                      <a:solidFill>
+                        <a:srgbClr val="D1D5DB"/>
+                      </a:solidFill>
+                      <a:prstDash val="solid"/>
+                      <a:round/>
+                      <a:headEnd type="none" w="med" len="med"/>
+                      <a:tailEnd type="none" w="med" len="med"/>
+                    </a:lnL>
+                    <a:lnR w="6350" cap="flat" cmpd="sng" algn="ctr">
+                      <a:solidFill>
+                        <a:srgbClr val="D1D5DB"/>
+                      </a:solidFill>
+                      <a:prstDash val="solid"/>
+                      <a:round/>
+                      <a:headEnd type="none" w="med" len="med"/>
+                      <a:tailEnd type="none" w="med" len="med"/>
+                    </a:lnR>
+                    <a:lnT w="6350" cap="flat" cmpd="sng" algn="ctr">
+                      <a:solidFill>
+                        <a:srgbClr val="D1D5DB"/>
+                      </a:solidFill>
+                      <a:prstDash val="solid"/>
+                      <a:round/>
+                      <a:headEnd type="none" w="med" len="med"/>
+                      <a:tailEnd type="none" w="med" len="med"/>
+                    </a:lnT>
+                    <a:lnB w="6350" cap="flat" cmpd="sng" algn="ctr">
+                      <a:solidFill>
+                        <a:srgbClr val="D1D5DB"/>
+                      </a:solidFill>
+                      <a:prstDash val="solid"/>
+                      <a:round/>
+                      <a:headEnd type="none" w="med" len="med"/>
+                      <a:tailEnd type="none" w="med" len="med"/>
+                    </a:lnB>
+                  </a:tcPr>
+                </a:tc>
+                <a:tc>
+                  <a:txBody>
+                    <a:bodyPr/>
+                    <a:lstStyle/>
+                    <a:p>
+                      <a:pPr algn="l" indent="0" marL="0">
+                        <a:buNone/>
+                      </a:pPr>
+                      <a:r>
+                        <a:rPr lang="en-US" sz="1400" dirty="0">
+                          <a:solidFill>
+                            <a:srgbClr val="000000"/>
+                          </a:solidFill>
+                          <a:latin typeface="Calibri" pitchFamily="34" charset="0"/>
+                          <a:ea typeface="Calibri" pitchFamily="34" charset="-122"/>
+                          <a:cs typeface="Calibri" pitchFamily="34" charset="-120"/>
+                        </a:rPr>
+                        <a:t>Remembers preferences &amp; past mistakes</a:t>
+                      </a:r>
+                      <a:endParaRPr lang="en-US" sz="1400" dirty="0">
+                        <a:latin typeface="Calibri" charset="0"/>
+                        <a:ea typeface="Calibri" charset="0"/>
+                        <a:cs typeface="Calibri" charset="0"/>
+                      </a:endParaRPr>
+                    </a:p>
+                  </a:txBody>
+                  <a:tcPr marL="91440" marR="91440" marT="45720" marB="45720">
+                    <a:lnL w="6350" cap="flat" cmpd="sng" algn="ctr">
+                      <a:solidFill>
+                        <a:srgbClr val="D1D5DB"/>
+                      </a:solidFill>
+                      <a:prstDash val="solid"/>
+                      <a:round/>
+                      <a:headEnd type="none" w="med" len="med"/>
+                      <a:tailEnd type="none" w="med" len="med"/>
+                    </a:lnL>
+                    <a:lnR w="6350" cap="flat" cmpd="sng" algn="ctr">
+                      <a:solidFill>
+                        <a:srgbClr val="D1D5DB"/>
+                      </a:solidFill>
+                      <a:prstDash val="solid"/>
+                      <a:round/>
+                      <a:headEnd type="none" w="med" len="med"/>
+                      <a:tailEnd type="none" w="med" len="med"/>
+                    </a:lnR>
+                    <a:lnT w="6350" cap="flat" cmpd="sng" algn="ctr">
+                      <a:solidFill>
+                        <a:srgbClr val="D1D5DB"/>
+                      </a:solidFill>
+                      <a:prstDash val="solid"/>
+                      <a:round/>
+                      <a:headEnd type="none" w="med" len="med"/>
+                      <a:tailEnd type="none" w="med" len="med"/>
+                    </a:lnT>
+                    <a:lnB w="6350" cap="flat" cmpd="sng" algn="ctr">
+                      <a:solidFill>
+                        <a:srgbClr val="D1D5DB"/>
+                      </a:solidFill>
+                      <a:prstDash val="solid"/>
+                      <a:round/>
+                      <a:headEnd type="none" w="med" len="med"/>
+                      <a:tailEnd type="none" w="med" len="med"/>
+                    </a:lnB>
+                  </a:tcPr>
+                </a:tc>
+              </a:tr>
+              <a:tr h="0">
+                <a:tc>
+                  <a:txBody>
+                    <a:bodyPr/>
+                    <a:lstStyle/>
+                    <a:p>
+                      <a:pPr algn="l" indent="0" marL="0">
+                        <a:buNone/>
+                      </a:pPr>
+                      <a:r>
+                        <a:rPr lang="en-US" sz="1400" dirty="0">
+                          <a:solidFill>
+                            <a:srgbClr val="000000"/>
+                          </a:solidFill>
+                          <a:latin typeface="Calibri" pitchFamily="34" charset="0"/>
+                          <a:ea typeface="Calibri" pitchFamily="34" charset="-122"/>
+                          <a:cs typeface="Calibri" pitchFamily="34" charset="-120"/>
+                        </a:rPr>
                         <a:t>Cost to run</a:t>
                       </a:r>
                       <a:endParaRPr lang="en-US" sz="1400" dirty="0">
@@ -8319,6 +9479,9 @@
                       <a:headEnd type="none" w="med" len="med"/>
                       <a:tailEnd type="none" w="med" len="med"/>
                     </a:lnB>
+                    <a:solidFill>
+                      <a:srgbClr val="F3F4F6"/>
+                    </a:solidFill>
                   </a:tcPr>
                 </a:tc>
                 <a:tc>
@@ -8384,6 +9547,9 @@
                       <a:headEnd type="none" w="med" len="med"/>
                       <a:tailEnd type="none" w="med" len="med"/>
                     </a:lnB>
+                    <a:solidFill>
+                      <a:srgbClr val="F3F4F6"/>
+                    </a:solidFill>
                   </a:tcPr>
                 </a:tc>
                 <a:tc>
@@ -8449,6 +9615,9 @@
                       <a:headEnd type="none" w="med" len="med"/>
                       <a:tailEnd type="none" w="med" len="med"/>
                     </a:lnB>
+                    <a:solidFill>
+                      <a:srgbClr val="F3F4F6"/>
+                    </a:solidFill>
                   </a:tcPr>
                 </a:tc>
                 <a:tc>
@@ -8514,6 +9683,9 @@
                       <a:headEnd type="none" w="med" len="med"/>
                       <a:tailEnd type="none" w="med" len="med"/>
                     </a:lnB>
+                    <a:solidFill>
+                      <a:srgbClr val="F3F4F6"/>
+                    </a:solidFill>
                   </a:tcPr>
                 </a:tc>
               </a:tr>

</xml_diff>